<commit_message>
hyperparamter search, updated website, finalized models
</commit_message>
<xml_diff>
--- a/submission/CMPT310_Group14_Digital_Poster.pptx
+++ b/submission/CMPT310_Group14_Digital_Poster.pptx
@@ -4,12 +4,12 @@
   <p:sldMasterIdLst>
     <p:sldMasterId id="2147483648" r:id="rId1"/>
   </p:sldMasterIdLst>
+  <p:notesMasterIdLst>
+    <p:notesMasterId r:id="rId3"/>
+  </p:notesMasterIdLst>
   <p:sldIdLst>
     <p:sldId id="256" r:id="rId2"/>
   </p:sldIdLst>
-  <p:notesMasterIdLst>
-    <p:notesMasterId r:id="rId3"/>
-  </p:notesMasterIdLst>
   <p:sldSz cx="32918400" cy="21945600"/>
   <p:notesSz cx="21945600" cy="32918400"/>
   <p:defaultTextStyle>
@@ -104,6 +104,11 @@
       </a:defRPr>
     </a:lvl9pPr>
   </p:defaultTextStyle>
+  <p:extLst>
+    <p:ext uri="{EFAFB233-063F-42B5-8137-9DF3F51BA10A}">
+      <p15:sldGuideLst xmlns:p15="http://schemas.microsoft.com/office/powerpoint/2012/main"/>
+    </p:ext>
+  </p:extLst>
 </p:presentation>
 </file>
 
@@ -129,234 +134,10 @@
           <a:chExt cx="0" cy="0"/>
         </a:xfrm>
       </p:grpSpPr>
-      <p:sp>
-        <p:nvSpPr>
-          <p:cNvPr id="2" name="Header Placeholder 1"/>
-          <p:cNvSpPr>
-            <a:spLocks noGrp="1"/>
-          </p:cNvSpPr>
-          <p:nvPr>
-            <p:ph type="hdr" sz="quarter"/>
-          </p:nvPr>
-        </p:nvSpPr>
-        <p:spPr>
-          <a:xfrm>
-            <a:off x="0" y="0"/>
-            <a:ext cx="2971800" cy="458788"/>
-          </a:xfrm>
-          <a:prstGeom prst="rect">
-            <a:avLst/>
-          </a:prstGeom>
-        </p:spPr>
-        <p:txBody>
-          <a:bodyPr vert="horz" lIns="91440" tIns="45720" rIns="91440" bIns="45720" rtlCol="0"/>
-          <a:lstStyle>
-            <a:lvl1pPr algn="l">
-              <a:defRPr sz="1200"/>
-            </a:lvl1pPr>
-          </a:lstStyle>
-          <a:p>
-            <a:endParaRPr lang="en-US"/>
-          </a:p>
-        </p:txBody>
-      </p:sp>
-      <p:sp>
-        <p:nvSpPr>
-          <p:cNvPr id="3" name="Date Placeholder 2"/>
-          <p:cNvSpPr>
-            <a:spLocks noGrp="1"/>
-          </p:cNvSpPr>
-          <p:nvPr>
-            <p:ph type="dt" idx="1"/>
-          </p:nvPr>
-        </p:nvSpPr>
-        <p:spPr>
-          <a:xfrm>
-            <a:off x="3884613" y="0"/>
-            <a:ext cx="2971800" cy="458788"/>
-          </a:xfrm>
-          <a:prstGeom prst="rect">
-            <a:avLst/>
-          </a:prstGeom>
-        </p:spPr>
-        <p:txBody>
-          <a:bodyPr vert="horz" lIns="91440" tIns="45720" rIns="91440" bIns="45720" rtlCol="0"/>
-          <a:lstStyle>
-            <a:lvl1pPr algn="r">
-              <a:defRPr sz="1200"/>
-            </a:lvl1pPr>
-          </a:lstStyle>
-          <a:p>
-            <a:fld id="{5282F153-3F37-0F45-9E97-73ACFA13230C}" type="datetimeFigureOut">
-              <a:rPr lang="en-US"/>
-              <a:t>7/23/19</a:t>
-            </a:fld>
-            <a:endParaRPr lang="en-US"/>
-          </a:p>
-        </p:txBody>
-      </p:sp>
-      <p:sp>
-        <p:nvSpPr>
-          <p:cNvPr id="4" name="Slide Image Placeholder 3"/>
-          <p:cNvSpPr>
-            <a:spLocks noGrp="1" noRot="1" noChangeAspect="1"/>
-          </p:cNvSpPr>
-          <p:nvPr>
-            <p:ph type="sldImg" idx="2"/>
-          </p:nvPr>
-        </p:nvSpPr>
-        <p:spPr>
-          <a:xfrm>
-            <a:off x="685800" y="1143000"/>
-            <a:ext cx="5486400" cy="3086100"/>
-          </a:xfrm>
-          <a:prstGeom prst="rect">
-            <a:avLst/>
-          </a:prstGeom>
-          <a:noFill/>
-          <a:ln w="12700">
-            <a:solidFill>
-              <a:prstClr val="black"/>
-            </a:solidFill>
-          </a:ln>
-        </p:spPr>
-        <p:txBody>
-          <a:bodyPr vert="horz" lIns="91440" tIns="45720" rIns="91440" bIns="45720" rtlCol="0" anchor="ctr"/>
-          <a:lstStyle/>
-          <a:p>
-            <a:endParaRPr lang="en-US"/>
-          </a:p>
-        </p:txBody>
-      </p:sp>
-      <p:sp>
-        <p:nvSpPr>
-          <p:cNvPr id="5" name="Notes Placeholder 4"/>
-          <p:cNvSpPr>
-            <a:spLocks noGrp="1"/>
-          </p:cNvSpPr>
-          <p:nvPr>
-            <p:ph type="body" sz="quarter" idx="3"/>
-          </p:nvPr>
-        </p:nvSpPr>
-        <p:spPr>
-          <a:xfrm>
-            <a:off x="685800" y="4400550"/>
-            <a:ext cx="5486400" cy="3600450"/>
-          </a:xfrm>
-          <a:prstGeom prst="rect">
-            <a:avLst/>
-          </a:prstGeom>
-        </p:spPr>
-        <p:txBody>
-          <a:bodyPr vert="horz" lIns="91440" tIns="45720" rIns="91440" bIns="45720" rtlCol="0"/>
-          <a:lstStyle/>
-          <a:p>
-            <a:pPr lvl="0"/>
-            <a:r>
-              <a:rPr lang="en-US"/>
-              <a:t>Click to edit Master text styles</a:t>
-            </a:r>
-          </a:p>
-          <a:p>
-            <a:pPr lvl="1"/>
-            <a:r>
-              <a:rPr lang="en-US"/>
-              <a:t>Second level</a:t>
-            </a:r>
-          </a:p>
-          <a:p>
-            <a:pPr lvl="2"/>
-            <a:r>
-              <a:rPr lang="en-US"/>
-              <a:t>Third level</a:t>
-            </a:r>
-          </a:p>
-          <a:p>
-            <a:pPr lvl="3"/>
-            <a:r>
-              <a:rPr lang="en-US"/>
-              <a:t>Fourth level</a:t>
-            </a:r>
-          </a:p>
-          <a:p>
-            <a:pPr lvl="4"/>
-            <a:r>
-              <a:rPr lang="en-US"/>
-              <a:t>Fifth level</a:t>
-            </a:r>
-          </a:p>
-        </p:txBody>
-      </p:sp>
-      <p:sp>
-        <p:nvSpPr>
-          <p:cNvPr id="6" name="Footer Placeholder 5"/>
-          <p:cNvSpPr>
-            <a:spLocks noGrp="1"/>
-          </p:cNvSpPr>
-          <p:nvPr>
-            <p:ph type="ftr" sz="quarter" idx="4"/>
-          </p:nvPr>
-        </p:nvSpPr>
-        <p:spPr>
-          <a:xfrm>
-            <a:off x="0" y="8685213"/>
-            <a:ext cx="2971800" cy="458787"/>
-          </a:xfrm>
-          <a:prstGeom prst="rect">
-            <a:avLst/>
-          </a:prstGeom>
-        </p:spPr>
-        <p:txBody>
-          <a:bodyPr vert="horz" lIns="91440" tIns="45720" rIns="91440" bIns="45720" rtlCol="0" anchor="b"/>
-          <a:lstStyle>
-            <a:lvl1pPr algn="l">
-              <a:defRPr sz="1200"/>
-            </a:lvl1pPr>
-          </a:lstStyle>
-          <a:p>
-            <a:endParaRPr lang="en-US"/>
-          </a:p>
-        </p:txBody>
-      </p:sp>
-      <p:sp>
-        <p:nvSpPr>
-          <p:cNvPr id="7" name="Slide Number Placeholder 6"/>
-          <p:cNvSpPr>
-            <a:spLocks noGrp="1"/>
-          </p:cNvSpPr>
-          <p:nvPr>
-            <p:ph type="sldNum" sz="quarter" idx="5"/>
-          </p:nvPr>
-        </p:nvSpPr>
-        <p:spPr>
-          <a:xfrm>
-            <a:off x="3884613" y="8685213"/>
-            <a:ext cx="2971800" cy="458787"/>
-          </a:xfrm>
-          <a:prstGeom prst="rect">
-            <a:avLst/>
-          </a:prstGeom>
-        </p:spPr>
-        <p:txBody>
-          <a:bodyPr vert="horz" lIns="91440" tIns="45720" rIns="91440" bIns="45720" rtlCol="0" anchor="b"/>
-          <a:lstStyle>
-            <a:lvl1pPr algn="r">
-              <a:defRPr sz="1200"/>
-            </a:lvl1pPr>
-          </a:lstStyle>
-          <a:p>
-            <a:fld id="{CE5E9CC1-C706-0F49-92D6-E571CC5EEA8F}" type="slidenum">
-              <a:rPr lang="en-US"/>
-              <a:t>‹#›</a:t>
-            </a:fld>
-            <a:endParaRPr lang="en-US"/>
-          </a:p>
-        </p:txBody>
-      </p:sp>
     </p:spTree>
     <p:extLst>
       <p:ext uri="{BB962C8B-B14F-4D97-AF65-F5344CB8AC3E}">
-        <p14:creationId xmlns:p14="http://schemas.microsoft.com/office/powerpoint/2010/main" val="1024086991"/>
+        <p14:creationId xmlns:p14="http://schemas.microsoft.com/office/powerpoint/2010/main" val="90432111"/>
       </p:ext>
     </p:extLst>
   </p:cSld>
@@ -500,10 +281,6 @@
           <a:bodyPr/>
           <a:lstStyle/>
           <a:p>
-            <a:r>
-              <a:rPr lang="en-US" dirty="0"/>
-              <a:t/>
-            </a:r>
             <a:endParaRPr lang="en-US" dirty="0"/>
           </a:p>
         </p:txBody>
@@ -577,6 +354,11 @@
 <file path=ppt/slideMasters/slideMaster1.xml><?xml version="1.0" encoding="utf-8"?>
 <p:sldMaster xmlns:a="http://schemas.openxmlformats.org/drawingml/2006/main" xmlns:r="http://schemas.openxmlformats.org/officeDocument/2006/relationships" xmlns:p="http://schemas.openxmlformats.org/presentationml/2006/main">
   <p:cSld>
+    <p:bg>
+      <p:bgRef idx="1001">
+        <a:schemeClr val="bg1"/>
+      </p:bgRef>
+    </p:bg>
     <p:spTree>
       <p:nvGrpSpPr>
         <p:cNvPr id="1" name=""/>
@@ -859,6 +641,7 @@
         <a:solidFill>
           <a:srgbClr val="F7F4F2"/>
         </a:solidFill>
+        <a:effectLst/>
       </p:bgPr>
     </p:bg>
     <p:spTree>
@@ -899,6 +682,13 @@
             <a:prstDash val="solid"/>
           </a:ln>
         </p:spPr>
+        <p:txBody>
+          <a:bodyPr/>
+          <a:lstStyle/>
+          <a:p>
+            <a:endParaRPr lang="en-CA"/>
+          </a:p>
+        </p:txBody>
       </p:sp>
       <p:sp>
         <p:nvSpPr>
@@ -924,17 +714,24 @@
             <a:prstDash val="solid"/>
           </a:ln>
         </p:spPr>
+        <p:txBody>
+          <a:bodyPr/>
+          <a:lstStyle/>
+          <a:p>
+            <a:endParaRPr lang="en-CA"/>
+          </a:p>
+        </p:txBody>
       </p:sp>
       <p:pic>
         <p:nvPicPr>
-          <p:cNvPr id="4" name="Image 0" descr="Simon Fraser University logo">    </p:cNvPr>
+          <p:cNvPr id="4" name="Image 0" descr="Simon Fraser University logo"/>
           <p:cNvPicPr>
             <a:picLocks noChangeAspect="1"/>
           </p:cNvPicPr>
           <p:nvPr/>
         </p:nvPicPr>
         <p:blipFill>
-          <a:blip r:embed="rId1"/>
+          <a:blip r:embed="rId3"/>
           <a:stretch>
             <a:fillRect/>
           </a:stretch>
@@ -972,7 +769,7 @@
           </a:bodyPr>
           <a:lstStyle/>
           <a:p>
-            <a:pPr algn="l" indent="0" marL="0">
+            <a:pPr marL="0" indent="0" algn="l">
               <a:buNone/>
             </a:pPr>
             <a:r>
@@ -989,7 +786,7 @@
             <a:endParaRPr lang="en-US" sz="1840" dirty="0"/>
           </a:p>
           <a:p>
-            <a:pPr algn="l" indent="0" marL="0">
+            <a:pPr marL="0" indent="0" algn="l">
               <a:buNone/>
             </a:pPr>
             <a:r>
@@ -1030,7 +827,7 @@
           </a:bodyPr>
           <a:lstStyle/>
           <a:p>
-            <a:pPr algn="ctr" indent="0" marL="0">
+            <a:pPr marL="0" indent="0" algn="ctr">
               <a:buNone/>
             </a:pPr>
             <a:r>
@@ -1047,7 +844,7 @@
             <a:endParaRPr lang="en-US" sz="5400" dirty="0"/>
           </a:p>
           <a:p>
-            <a:pPr algn="ctr" indent="0" marL="0">
+            <a:pPr marL="0" indent="0" algn="ctr">
               <a:buNone/>
             </a:pPr>
             <a:r>
@@ -1088,7 +885,7 @@
           </a:bodyPr>
           <a:lstStyle/>
           <a:p>
-            <a:pPr algn="ctr" indent="0" marL="0">
+            <a:pPr marL="0" indent="0" algn="ctr">
               <a:buNone/>
             </a:pPr>
             <a:r>
@@ -1129,7 +926,7 @@
           </a:bodyPr>
           <a:lstStyle/>
           <a:p>
-            <a:pPr algn="ctr" indent="0" marL="0">
+            <a:pPr marL="0" indent="0" algn="ctr">
               <a:buNone/>
             </a:pPr>
             <a:r>
@@ -1170,7 +967,7 @@
           </a:bodyPr>
           <a:lstStyle/>
           <a:p>
-            <a:pPr algn="ctr" indent="0" marL="0">
+            <a:pPr marL="0" indent="0" algn="ctr">
               <a:buNone/>
             </a:pPr>
             <a:r>
@@ -1214,13 +1011,20 @@
             <a:prstDash val="solid"/>
           </a:ln>
           <a:effectLst>
-            <a:outerShdw sx="100000" sy="100000" kx="0" ky="0" algn="bl" rotWithShape="0" blurRad="19050" dist="50800" dir="2700000">
+            <a:outerShdw blurRad="19050" dist="50800" dir="2700000" algn="bl" rotWithShape="0">
               <a:srgbClr val="888888">
                 <a:alpha val="12000"/>
               </a:srgbClr>
             </a:outerShdw>
           </a:effectLst>
         </p:spPr>
+        <p:txBody>
+          <a:bodyPr/>
+          <a:lstStyle/>
+          <a:p>
+            <a:endParaRPr lang="en-CA"/>
+          </a:p>
+        </p:txBody>
       </p:sp>
       <p:sp>
         <p:nvSpPr>
@@ -1248,6 +1052,13 @@
             <a:prstDash val="solid"/>
           </a:ln>
         </p:spPr>
+        <p:txBody>
+          <a:bodyPr/>
+          <a:lstStyle/>
+          <a:p>
+            <a:endParaRPr lang="en-CA"/>
+          </a:p>
+        </p:txBody>
       </p:sp>
       <p:sp>
         <p:nvSpPr>
@@ -1272,7 +1083,7 @@
           </a:bodyPr>
           <a:lstStyle/>
           <a:p>
-            <a:pPr algn="l" indent="0" marL="0">
+            <a:pPr marL="0" indent="0" algn="l">
               <a:buNone/>
             </a:pPr>
             <a:r>
@@ -1313,7 +1124,7 @@
           </a:bodyPr>
           <a:lstStyle/>
           <a:p>
-            <a:pPr algn="l" indent="0" marL="0">
+            <a:pPr marL="0" indent="0" algn="l">
               <a:buNone/>
             </a:pPr>
             <a:r>
@@ -1330,13 +1141,13 @@
             <a:endParaRPr lang="en-US" sz="1820" dirty="0"/>
           </a:p>
           <a:p>
-            <a:pPr algn="l" indent="0" marL="0">
+            <a:pPr marL="0" indent="0" algn="l">
               <a:buNone/>
             </a:pPr>
             <a:endParaRPr lang="en-US" sz="1820" dirty="0"/>
           </a:p>
           <a:p>
-            <a:pPr algn="l" indent="0" marL="0">
+            <a:pPr marL="0" indent="0" algn="l">
               <a:buNone/>
             </a:pPr>
             <a:r>
@@ -1380,13 +1191,20 @@
             <a:prstDash val="solid"/>
           </a:ln>
           <a:effectLst>
-            <a:outerShdw sx="100000" sy="100000" kx="0" ky="0" algn="bl" rotWithShape="0" blurRad="19050" dist="50800" dir="2700000">
+            <a:outerShdw blurRad="19050" dist="50800" dir="2700000" algn="bl" rotWithShape="0">
               <a:srgbClr val="888888">
                 <a:alpha val="12000"/>
               </a:srgbClr>
             </a:outerShdw>
           </a:effectLst>
         </p:spPr>
+        <p:txBody>
+          <a:bodyPr/>
+          <a:lstStyle/>
+          <a:p>
+            <a:endParaRPr lang="en-CA"/>
+          </a:p>
+        </p:txBody>
       </p:sp>
       <p:sp>
         <p:nvSpPr>
@@ -1414,6 +1232,13 @@
             <a:prstDash val="solid"/>
           </a:ln>
         </p:spPr>
+        <p:txBody>
+          <a:bodyPr/>
+          <a:lstStyle/>
+          <a:p>
+            <a:endParaRPr lang="en-CA"/>
+          </a:p>
+        </p:txBody>
       </p:sp>
       <p:sp>
         <p:nvSpPr>
@@ -1438,7 +1263,7 @@
           </a:bodyPr>
           <a:lstStyle/>
           <a:p>
-            <a:pPr algn="l" indent="0" marL="0">
+            <a:pPr marL="0" indent="0" algn="l">
               <a:buNone/>
             </a:pPr>
             <a:r>
@@ -1479,7 +1304,7 @@
           </a:bodyPr>
           <a:lstStyle/>
           <a:p>
-            <a:pPr algn="ctr" indent="0" marL="0">
+            <a:pPr marL="0" indent="0" algn="ctr">
               <a:buNone/>
             </a:pPr>
             <a:r>
@@ -1496,7 +1321,7 @@
             <a:endParaRPr lang="en-US" sz="2000" dirty="0"/>
           </a:p>
           <a:p>
-            <a:pPr algn="ctr" indent="0" marL="0">
+            <a:pPr marL="0" indent="0" algn="ctr">
               <a:buNone/>
             </a:pPr>
             <a:r>
@@ -1540,6 +1365,13 @@
             <a:prstDash val="solid"/>
           </a:ln>
         </p:spPr>
+        <p:txBody>
+          <a:bodyPr/>
+          <a:lstStyle/>
+          <a:p>
+            <a:endParaRPr lang="en-CA"/>
+          </a:p>
+        </p:txBody>
       </p:sp>
       <p:sp>
         <p:nvSpPr>
@@ -1564,7 +1396,7 @@
           </a:bodyPr>
           <a:lstStyle/>
           <a:p>
-            <a:pPr algn="ctr" indent="0" marL="0">
+            <a:pPr marL="0" indent="0" algn="ctr">
               <a:buNone/>
             </a:pPr>
             <a:r>
@@ -1581,7 +1413,7 @@
             <a:endParaRPr lang="en-US" sz="1760" dirty="0"/>
           </a:p>
           <a:p>
-            <a:pPr algn="ctr" indent="0" marL="0">
+            <a:pPr marL="0" indent="0" algn="ctr">
               <a:buNone/>
             </a:pPr>
             <a:r>
@@ -1622,7 +1454,7 @@
           </a:bodyPr>
           <a:lstStyle/>
           <a:p>
-            <a:pPr algn="ctr" indent="0" marL="0">
+            <a:pPr marL="0" indent="0" algn="ctr">
               <a:buNone/>
             </a:pPr>
             <a:r>
@@ -1666,13 +1498,20 @@
             <a:prstDash val="solid"/>
           </a:ln>
           <a:effectLst>
-            <a:outerShdw sx="100000" sy="100000" kx="0" ky="0" algn="bl" rotWithShape="0" blurRad="19050" dist="50800" dir="2700000">
+            <a:outerShdw blurRad="19050" dist="50800" dir="2700000" algn="bl" rotWithShape="0">
               <a:srgbClr val="888888">
                 <a:alpha val="12000"/>
               </a:srgbClr>
             </a:outerShdw>
           </a:effectLst>
         </p:spPr>
+        <p:txBody>
+          <a:bodyPr/>
+          <a:lstStyle/>
+          <a:p>
+            <a:endParaRPr lang="en-CA"/>
+          </a:p>
+        </p:txBody>
       </p:sp>
       <p:sp>
         <p:nvSpPr>
@@ -1700,6 +1539,13 @@
             <a:prstDash val="solid"/>
           </a:ln>
         </p:spPr>
+        <p:txBody>
+          <a:bodyPr/>
+          <a:lstStyle/>
+          <a:p>
+            <a:endParaRPr lang="en-CA"/>
+          </a:p>
+        </p:txBody>
       </p:sp>
       <p:sp>
         <p:nvSpPr>
@@ -1724,7 +1570,7 @@
           </a:bodyPr>
           <a:lstStyle/>
           <a:p>
-            <a:pPr algn="l" indent="0" marL="0">
+            <a:pPr marL="0" indent="0" algn="l">
               <a:buNone/>
             </a:pPr>
             <a:r>
@@ -1765,7 +1611,7 @@
           </a:bodyPr>
           <a:lstStyle/>
           <a:p>
-            <a:pPr algn="l" indent="0" marL="0">
+            <a:pPr marL="0" indent="0" algn="l">
               <a:buNone/>
             </a:pPr>
             <a:r>
@@ -1809,6 +1655,13 @@
             <a:prstDash val="solid"/>
           </a:ln>
         </p:spPr>
+        <p:txBody>
+          <a:bodyPr/>
+          <a:lstStyle/>
+          <a:p>
+            <a:endParaRPr lang="en-CA"/>
+          </a:p>
+        </p:txBody>
       </p:sp>
       <p:sp>
         <p:nvSpPr>
@@ -1833,7 +1686,7 @@
           </a:bodyPr>
           <a:lstStyle/>
           <a:p>
-            <a:pPr algn="l" indent="0" marL="0">
+            <a:pPr marL="0" indent="0" algn="l">
               <a:buNone/>
             </a:pPr>
             <a:r>
@@ -1850,13 +1703,13 @@
             <a:endParaRPr lang="en-US" sz="1620" dirty="0"/>
           </a:p>
           <a:p>
-            <a:pPr algn="l" indent="0" marL="0">
+            <a:pPr marL="0" indent="0" algn="l">
               <a:buNone/>
             </a:pPr>
             <a:endParaRPr lang="en-US" sz="1620" dirty="0"/>
           </a:p>
           <a:p>
-            <a:pPr algn="l" indent="0" marL="0">
+            <a:pPr marL="0" indent="0" algn="l">
               <a:buNone/>
             </a:pPr>
             <a:r>
@@ -1873,7 +1726,7 @@
             <a:endParaRPr lang="en-US" sz="1620" dirty="0"/>
           </a:p>
           <a:p>
-            <a:pPr algn="l" indent="0" marL="0">
+            <a:pPr marL="0" indent="0" algn="l">
               <a:buNone/>
             </a:pPr>
             <a:r>
@@ -1890,7 +1743,7 @@
             <a:endParaRPr lang="en-US" sz="1620" dirty="0"/>
           </a:p>
           <a:p>
-            <a:pPr algn="l" indent="0" marL="0">
+            <a:pPr marL="0" indent="0" algn="l">
               <a:buNone/>
             </a:pPr>
             <a:r>
@@ -1934,6 +1787,13 @@
             <a:prstDash val="solid"/>
           </a:ln>
         </p:spPr>
+        <p:txBody>
+          <a:bodyPr/>
+          <a:lstStyle/>
+          <a:p>
+            <a:endParaRPr lang="en-CA"/>
+          </a:p>
+        </p:txBody>
       </p:sp>
       <p:sp>
         <p:nvSpPr>
@@ -1958,7 +1818,7 @@
           </a:bodyPr>
           <a:lstStyle/>
           <a:p>
-            <a:pPr algn="l" indent="0" marL="0">
+            <a:pPr marL="0" indent="0" algn="l">
               <a:buNone/>
             </a:pPr>
             <a:r>
@@ -1975,13 +1835,13 @@
             <a:endParaRPr lang="en-US" sz="1550" dirty="0"/>
           </a:p>
           <a:p>
-            <a:pPr algn="l" indent="0" marL="0">
+            <a:pPr marL="0" indent="0" algn="l">
               <a:buNone/>
             </a:pPr>
             <a:endParaRPr lang="en-US" sz="1550" dirty="0"/>
           </a:p>
           <a:p>
-            <a:pPr algn="l" indent="0" marL="0">
+            <a:pPr marL="0" indent="0" algn="l">
               <a:buNone/>
             </a:pPr>
             <a:r>
@@ -1998,7 +1858,7 @@
             <a:endParaRPr lang="en-US" sz="1550" dirty="0"/>
           </a:p>
           <a:p>
-            <a:pPr algn="l" indent="0" marL="0">
+            <a:pPr marL="0" indent="0" algn="l">
               <a:buNone/>
             </a:pPr>
             <a:r>
@@ -2015,7 +1875,7 @@
             <a:endParaRPr lang="en-US" sz="1550" dirty="0"/>
           </a:p>
           <a:p>
-            <a:pPr algn="l" indent="0" marL="0">
+            <a:pPr marL="0" indent="0" algn="l">
               <a:buNone/>
             </a:pPr>
             <a:r>
@@ -2032,7 +1892,7 @@
             <a:endParaRPr lang="en-US" sz="1550" dirty="0"/>
           </a:p>
           <a:p>
-            <a:pPr algn="l" indent="0" marL="0">
+            <a:pPr marL="0" indent="0" algn="l">
               <a:buNone/>
             </a:pPr>
             <a:r>
@@ -2073,7 +1933,7 @@
           </a:bodyPr>
           <a:lstStyle/>
           <a:p>
-            <a:pPr algn="l" indent="0" marL="0">
+            <a:pPr marL="0" indent="0" algn="l">
               <a:buNone/>
             </a:pPr>
             <a:r>
@@ -2114,7 +1974,7 @@
           </a:bodyPr>
           <a:lstStyle/>
           <a:p>
-            <a:pPr algn="l" indent="0" marL="0">
+            <a:pPr marL="0" indent="0" algn="l">
               <a:buNone/>
             </a:pPr>
             <a:r>
@@ -2131,7 +1991,7 @@
             <a:endParaRPr lang="en-US" sz="1530" dirty="0"/>
           </a:p>
           <a:p>
-            <a:pPr algn="l" indent="0" marL="0">
+            <a:pPr marL="0" indent="0" algn="l">
               <a:buNone/>
             </a:pPr>
             <a:r>
@@ -2148,7 +2008,7 @@
             <a:endParaRPr lang="en-US" sz="1530" dirty="0"/>
           </a:p>
           <a:p>
-            <a:pPr algn="l" indent="0" marL="0">
+            <a:pPr marL="0" indent="0" algn="l">
               <a:buNone/>
             </a:pPr>
             <a:r>
@@ -2165,7 +2025,7 @@
             <a:endParaRPr lang="en-US" sz="1530" dirty="0"/>
           </a:p>
           <a:p>
-            <a:pPr algn="l" indent="0" marL="0">
+            <a:pPr marL="0" indent="0" algn="l">
               <a:buNone/>
             </a:pPr>
             <a:r>
@@ -2182,7 +2042,7 @@
             <a:endParaRPr lang="en-US" sz="1530" dirty="0"/>
           </a:p>
           <a:p>
-            <a:pPr algn="l" indent="0" marL="0">
+            <a:pPr marL="0" indent="0" algn="l">
               <a:buNone/>
             </a:pPr>
             <a:r>
@@ -2199,13 +2059,13 @@
             <a:endParaRPr lang="en-US" sz="1530" dirty="0"/>
           </a:p>
           <a:p>
-            <a:pPr algn="l" indent="0" marL="0">
+            <a:pPr marL="0" indent="0" algn="l">
               <a:buNone/>
             </a:pPr>
             <a:endParaRPr lang="en-US" sz="1530" dirty="0"/>
           </a:p>
           <a:p>
-            <a:pPr algn="l" indent="0" marL="0">
+            <a:pPr marL="0" indent="0" algn="l">
               <a:buNone/>
             </a:pPr>
             <a:r>
@@ -2249,13 +2109,20 @@
             <a:prstDash val="solid"/>
           </a:ln>
           <a:effectLst>
-            <a:outerShdw sx="100000" sy="100000" kx="0" ky="0" algn="bl" rotWithShape="0" blurRad="19050" dist="50800" dir="2700000">
+            <a:outerShdw blurRad="19050" dist="50800" dir="2700000" algn="bl" rotWithShape="0">
               <a:srgbClr val="888888">
                 <a:alpha val="12000"/>
               </a:srgbClr>
             </a:outerShdw>
           </a:effectLst>
         </p:spPr>
+        <p:txBody>
+          <a:bodyPr/>
+          <a:lstStyle/>
+          <a:p>
+            <a:endParaRPr lang="en-CA"/>
+          </a:p>
+        </p:txBody>
       </p:sp>
       <p:sp>
         <p:nvSpPr>
@@ -2283,6 +2150,13 @@
             <a:prstDash val="solid"/>
           </a:ln>
         </p:spPr>
+        <p:txBody>
+          <a:bodyPr/>
+          <a:lstStyle/>
+          <a:p>
+            <a:endParaRPr lang="en-CA"/>
+          </a:p>
+        </p:txBody>
       </p:sp>
       <p:sp>
         <p:nvSpPr>
@@ -2307,7 +2181,7 @@
           </a:bodyPr>
           <a:lstStyle/>
           <a:p>
-            <a:pPr algn="l" indent="0" marL="0">
+            <a:pPr marL="0" indent="0" algn="l">
               <a:buNone/>
             </a:pPr>
             <a:r>
@@ -2351,6 +2225,13 @@
             <a:prstDash val="solid"/>
           </a:ln>
         </p:spPr>
+        <p:txBody>
+          <a:bodyPr/>
+          <a:lstStyle/>
+          <a:p>
+            <a:endParaRPr lang="en-CA"/>
+          </a:p>
+        </p:txBody>
       </p:sp>
       <p:sp>
         <p:nvSpPr>
@@ -2376,6 +2257,13 @@
             <a:prstDash val="solid"/>
           </a:ln>
         </p:spPr>
+        <p:txBody>
+          <a:bodyPr/>
+          <a:lstStyle/>
+          <a:p>
+            <a:endParaRPr lang="en-CA"/>
+          </a:p>
+        </p:txBody>
       </p:sp>
       <p:sp>
         <p:nvSpPr>
@@ -2400,7 +2288,7 @@
           </a:bodyPr>
           <a:lstStyle/>
           <a:p>
-            <a:pPr algn="ctr" indent="0" marL="0">
+            <a:pPr marL="0" indent="0" algn="ctr">
               <a:buNone/>
             </a:pPr>
             <a:r>
@@ -2441,7 +2329,7 @@
           </a:bodyPr>
           <a:lstStyle/>
           <a:p>
-            <a:pPr algn="ctr" indent="0" marL="0">
+            <a:pPr marL="0" indent="0" algn="ctr">
               <a:buNone/>
             </a:pPr>
             <a:r>
@@ -2482,7 +2370,7 @@
           </a:bodyPr>
           <a:lstStyle/>
           <a:p>
-            <a:pPr algn="ctr" indent="0" marL="0">
+            <a:pPr marL="0" indent="0" algn="ctr">
               <a:buNone/>
             </a:pPr>
             <a:r>
@@ -2499,7 +2387,7 @@
             <a:endParaRPr lang="en-US" sz="1280" dirty="0"/>
           </a:p>
           <a:p>
-            <a:pPr algn="ctr" indent="0" marL="0">
+            <a:pPr marL="0" indent="0" algn="ctr">
               <a:buNone/>
             </a:pPr>
             <a:r>
@@ -2541,6 +2429,13 @@
             <a:prstDash val="solid"/>
           </a:ln>
         </p:spPr>
+        <p:txBody>
+          <a:bodyPr/>
+          <a:lstStyle/>
+          <a:p>
+            <a:endParaRPr lang="en-CA"/>
+          </a:p>
+        </p:txBody>
       </p:sp>
       <p:sp>
         <p:nvSpPr>
@@ -2568,6 +2463,13 @@
             <a:prstDash val="solid"/>
           </a:ln>
         </p:spPr>
+        <p:txBody>
+          <a:bodyPr/>
+          <a:lstStyle/>
+          <a:p>
+            <a:endParaRPr lang="en-CA"/>
+          </a:p>
+        </p:txBody>
       </p:sp>
       <p:sp>
         <p:nvSpPr>
@@ -2593,6 +2495,13 @@
             <a:prstDash val="solid"/>
           </a:ln>
         </p:spPr>
+        <p:txBody>
+          <a:bodyPr/>
+          <a:lstStyle/>
+          <a:p>
+            <a:endParaRPr lang="en-CA"/>
+          </a:p>
+        </p:txBody>
       </p:sp>
       <p:sp>
         <p:nvSpPr>
@@ -2617,7 +2526,7 @@
           </a:bodyPr>
           <a:lstStyle/>
           <a:p>
-            <a:pPr algn="ctr" indent="0" marL="0">
+            <a:pPr marL="0" indent="0" algn="ctr">
               <a:buNone/>
             </a:pPr>
             <a:r>
@@ -2658,7 +2567,7 @@
           </a:bodyPr>
           <a:lstStyle/>
           <a:p>
-            <a:pPr algn="ctr" indent="0" marL="0">
+            <a:pPr marL="0" indent="0" algn="ctr">
               <a:buNone/>
             </a:pPr>
             <a:r>
@@ -2699,7 +2608,7 @@
           </a:bodyPr>
           <a:lstStyle/>
           <a:p>
-            <a:pPr algn="ctr" indent="0" marL="0">
+            <a:pPr marL="0" indent="0" algn="ctr">
               <a:buNone/>
             </a:pPr>
             <a:r>
@@ -2716,7 +2625,7 @@
             <a:endParaRPr lang="en-US" sz="1280" dirty="0"/>
           </a:p>
           <a:p>
-            <a:pPr algn="ctr" indent="0" marL="0">
+            <a:pPr marL="0" indent="0" algn="ctr">
               <a:buNone/>
             </a:pPr>
             <a:r>
@@ -2758,6 +2667,13 @@
             <a:prstDash val="solid"/>
           </a:ln>
         </p:spPr>
+        <p:txBody>
+          <a:bodyPr/>
+          <a:lstStyle/>
+          <a:p>
+            <a:endParaRPr lang="en-CA"/>
+          </a:p>
+        </p:txBody>
       </p:sp>
       <p:sp>
         <p:nvSpPr>
@@ -2785,6 +2701,13 @@
             <a:prstDash val="solid"/>
           </a:ln>
         </p:spPr>
+        <p:txBody>
+          <a:bodyPr/>
+          <a:lstStyle/>
+          <a:p>
+            <a:endParaRPr lang="en-CA"/>
+          </a:p>
+        </p:txBody>
       </p:sp>
       <p:sp>
         <p:nvSpPr>
@@ -2810,6 +2733,13 @@
             <a:prstDash val="solid"/>
           </a:ln>
         </p:spPr>
+        <p:txBody>
+          <a:bodyPr/>
+          <a:lstStyle/>
+          <a:p>
+            <a:endParaRPr lang="en-CA"/>
+          </a:p>
+        </p:txBody>
       </p:sp>
       <p:sp>
         <p:nvSpPr>
@@ -2834,7 +2764,7 @@
           </a:bodyPr>
           <a:lstStyle/>
           <a:p>
-            <a:pPr algn="ctr" indent="0" marL="0">
+            <a:pPr marL="0" indent="0" algn="ctr">
               <a:buNone/>
             </a:pPr>
             <a:r>
@@ -2875,7 +2805,7 @@
           </a:bodyPr>
           <a:lstStyle/>
           <a:p>
-            <a:pPr algn="ctr" indent="0" marL="0">
+            <a:pPr marL="0" indent="0" algn="ctr">
               <a:buNone/>
             </a:pPr>
             <a:r>
@@ -2916,7 +2846,7 @@
           </a:bodyPr>
           <a:lstStyle/>
           <a:p>
-            <a:pPr algn="ctr" indent="0" marL="0">
+            <a:pPr marL="0" indent="0" algn="ctr">
               <a:buNone/>
             </a:pPr>
             <a:r>
@@ -2933,7 +2863,7 @@
             <a:endParaRPr lang="en-US" sz="1280" dirty="0"/>
           </a:p>
           <a:p>
-            <a:pPr algn="ctr" indent="0" marL="0">
+            <a:pPr marL="0" indent="0" algn="ctr">
               <a:buNone/>
             </a:pPr>
             <a:r>
@@ -2975,6 +2905,13 @@
             <a:prstDash val="solid"/>
           </a:ln>
         </p:spPr>
+        <p:txBody>
+          <a:bodyPr/>
+          <a:lstStyle/>
+          <a:p>
+            <a:endParaRPr lang="en-CA"/>
+          </a:p>
+        </p:txBody>
       </p:sp>
       <p:sp>
         <p:nvSpPr>
@@ -3002,6 +2939,13 @@
             <a:prstDash val="solid"/>
           </a:ln>
         </p:spPr>
+        <p:txBody>
+          <a:bodyPr/>
+          <a:lstStyle/>
+          <a:p>
+            <a:endParaRPr lang="en-CA"/>
+          </a:p>
+        </p:txBody>
       </p:sp>
       <p:sp>
         <p:nvSpPr>
@@ -3027,6 +2971,13 @@
             <a:prstDash val="solid"/>
           </a:ln>
         </p:spPr>
+        <p:txBody>
+          <a:bodyPr/>
+          <a:lstStyle/>
+          <a:p>
+            <a:endParaRPr lang="en-CA"/>
+          </a:p>
+        </p:txBody>
       </p:sp>
       <p:sp>
         <p:nvSpPr>
@@ -3051,7 +3002,7 @@
           </a:bodyPr>
           <a:lstStyle/>
           <a:p>
-            <a:pPr algn="ctr" indent="0" marL="0">
+            <a:pPr marL="0" indent="0" algn="ctr">
               <a:buNone/>
             </a:pPr>
             <a:r>
@@ -3092,7 +3043,7 @@
           </a:bodyPr>
           <a:lstStyle/>
           <a:p>
-            <a:pPr algn="ctr" indent="0" marL="0">
+            <a:pPr marL="0" indent="0" algn="ctr">
               <a:buNone/>
             </a:pPr>
             <a:r>
@@ -3133,7 +3084,7 @@
           </a:bodyPr>
           <a:lstStyle/>
           <a:p>
-            <a:pPr algn="ctr" indent="0" marL="0">
+            <a:pPr marL="0" indent="0" algn="ctr">
               <a:buNone/>
             </a:pPr>
             <a:r>
@@ -3150,7 +3101,7 @@
             <a:endParaRPr lang="en-US" sz="1280" dirty="0"/>
           </a:p>
           <a:p>
-            <a:pPr algn="ctr" indent="0" marL="0">
+            <a:pPr marL="0" indent="0" algn="ctr">
               <a:buNone/>
             </a:pPr>
             <a:r>
@@ -3192,6 +3143,13 @@
             <a:prstDash val="solid"/>
           </a:ln>
         </p:spPr>
+        <p:txBody>
+          <a:bodyPr/>
+          <a:lstStyle/>
+          <a:p>
+            <a:endParaRPr lang="en-CA"/>
+          </a:p>
+        </p:txBody>
       </p:sp>
       <p:sp>
         <p:nvSpPr>
@@ -3201,7 +3159,7 @@
         </p:nvSpPr>
         <p:spPr>
           <a:xfrm>
-            <a:off x="20007072" y="4882896"/>
+            <a:off x="19933920" y="4846320"/>
             <a:ext cx="2057400" cy="2103120"/>
           </a:xfrm>
           <a:prstGeom prst="roundRect">
@@ -3219,6 +3177,13 @@
             <a:prstDash val="solid"/>
           </a:ln>
         </p:spPr>
+        <p:txBody>
+          <a:bodyPr/>
+          <a:lstStyle/>
+          <a:p>
+            <a:endParaRPr lang="en-CA"/>
+          </a:p>
+        </p:txBody>
       </p:sp>
       <p:sp>
         <p:nvSpPr>
@@ -3244,6 +3209,13 @@
             <a:prstDash val="solid"/>
           </a:ln>
         </p:spPr>
+        <p:txBody>
+          <a:bodyPr/>
+          <a:lstStyle/>
+          <a:p>
+            <a:endParaRPr lang="en-CA"/>
+          </a:p>
+        </p:txBody>
       </p:sp>
       <p:sp>
         <p:nvSpPr>
@@ -3268,7 +3240,7 @@
           </a:bodyPr>
           <a:lstStyle/>
           <a:p>
-            <a:pPr algn="ctr" indent="0" marL="0">
+            <a:pPr marL="0" indent="0" algn="ctr">
               <a:buNone/>
             </a:pPr>
             <a:r>
@@ -3309,7 +3281,7 @@
           </a:bodyPr>
           <a:lstStyle/>
           <a:p>
-            <a:pPr algn="ctr" indent="0" marL="0">
+            <a:pPr marL="0" indent="0" algn="ctr">
               <a:buNone/>
             </a:pPr>
             <a:r>
@@ -3350,7 +3322,7 @@
           </a:bodyPr>
           <a:lstStyle/>
           <a:p>
-            <a:pPr algn="ctr" indent="0" marL="0">
+            <a:pPr marL="0" indent="0" algn="ctr">
               <a:buNone/>
             </a:pPr>
             <a:r>
@@ -3367,7 +3339,7 @@
             <a:endParaRPr lang="en-US" sz="1280" dirty="0"/>
           </a:p>
           <a:p>
-            <a:pPr algn="ctr" indent="0" marL="0">
+            <a:pPr marL="0" indent="0" algn="ctr">
               <a:buNone/>
             </a:pPr>
             <a:r>
@@ -3411,6 +3383,13 @@
             <a:prstDash val="solid"/>
           </a:ln>
         </p:spPr>
+        <p:txBody>
+          <a:bodyPr/>
+          <a:lstStyle/>
+          <a:p>
+            <a:endParaRPr lang="en-CA"/>
+          </a:p>
+        </p:txBody>
       </p:sp>
       <p:sp>
         <p:nvSpPr>
@@ -3435,7 +3414,7 @@
           </a:bodyPr>
           <a:lstStyle/>
           <a:p>
-            <a:pPr algn="ctr" indent="0" marL="0">
+            <a:pPr marL="0" indent="0" algn="ctr">
               <a:buNone/>
             </a:pPr>
             <a:r>
@@ -3479,13 +3458,20 @@
             <a:prstDash val="solid"/>
           </a:ln>
           <a:effectLst>
-            <a:outerShdw sx="100000" sy="100000" kx="0" ky="0" algn="bl" rotWithShape="0" blurRad="19050" dist="50800" dir="2700000">
+            <a:outerShdw blurRad="19050" dist="50800" dir="2700000" algn="bl" rotWithShape="0">
               <a:srgbClr val="888888">
                 <a:alpha val="12000"/>
               </a:srgbClr>
             </a:outerShdw>
           </a:effectLst>
         </p:spPr>
+        <p:txBody>
+          <a:bodyPr/>
+          <a:lstStyle/>
+          <a:p>
+            <a:endParaRPr lang="en-CA"/>
+          </a:p>
+        </p:txBody>
       </p:sp>
       <p:sp>
         <p:nvSpPr>
@@ -3513,6 +3499,13 @@
             <a:prstDash val="solid"/>
           </a:ln>
         </p:spPr>
+        <p:txBody>
+          <a:bodyPr/>
+          <a:lstStyle/>
+          <a:p>
+            <a:endParaRPr lang="en-CA"/>
+          </a:p>
+        </p:txBody>
       </p:sp>
       <p:sp>
         <p:nvSpPr>
@@ -3537,7 +3530,7 @@
           </a:bodyPr>
           <a:lstStyle/>
           <a:p>
-            <a:pPr algn="l" indent="0" marL="0">
+            <a:pPr marL="0" indent="0" algn="l">
               <a:buNone/>
             </a:pPr>
             <a:r>
@@ -3557,14 +3550,14 @@
       </p:sp>
       <p:pic>
         <p:nvPicPr>
-          <p:cNvPr id="68" name="Image 1" descr="Bar chart comparing five-fold accuracy and macro-F1 across baseline and random-forest experiments">    </p:cNvPr>
+          <p:cNvPr id="68" name="Image 1" descr="Bar chart comparing five-fold accuracy and macro-F1 across baseline and random-forest experiments"/>
           <p:cNvPicPr>
             <a:picLocks noChangeAspect="1"/>
           </p:cNvPicPr>
           <p:nvPr/>
         </p:nvPicPr>
         <p:blipFill>
-          <a:blip r:embed="rId2"/>
+          <a:blip r:embed="rId4"/>
           <a:stretch>
             <a:fillRect/>
           </a:stretch>
@@ -3605,13 +3598,20 @@
             <a:prstDash val="solid"/>
           </a:ln>
           <a:effectLst>
-            <a:outerShdw sx="100000" sy="100000" kx="0" ky="0" algn="bl" rotWithShape="0" blurRad="19050" dist="50800" dir="2700000">
+            <a:outerShdw blurRad="19050" dist="50800" dir="2700000" algn="bl" rotWithShape="0">
               <a:srgbClr val="888888">
                 <a:alpha val="12000"/>
               </a:srgbClr>
             </a:outerShdw>
           </a:effectLst>
         </p:spPr>
+        <p:txBody>
+          <a:bodyPr/>
+          <a:lstStyle/>
+          <a:p>
+            <a:endParaRPr lang="en-CA"/>
+          </a:p>
+        </p:txBody>
       </p:sp>
       <p:sp>
         <p:nvSpPr>
@@ -3639,6 +3639,13 @@
             <a:prstDash val="solid"/>
           </a:ln>
         </p:spPr>
+        <p:txBody>
+          <a:bodyPr/>
+          <a:lstStyle/>
+          <a:p>
+            <a:endParaRPr lang="en-CA"/>
+          </a:p>
+        </p:txBody>
       </p:sp>
       <p:sp>
         <p:nvSpPr>
@@ -3663,7 +3670,7 @@
           </a:bodyPr>
           <a:lstStyle/>
           <a:p>
-            <a:pPr algn="l" indent="0" marL="0">
+            <a:pPr marL="0" indent="0" algn="l">
               <a:buNone/>
             </a:pPr>
             <a:r>
@@ -3704,7 +3711,7 @@
           </a:bodyPr>
           <a:lstStyle/>
           <a:p>
-            <a:pPr algn="l" indent="0" marL="0">
+            <a:pPr marL="0" indent="0" algn="l">
               <a:buNone/>
             </a:pPr>
             <a:r>
@@ -3721,7 +3728,7 @@
             <a:endParaRPr lang="en-US" sz="1720" dirty="0"/>
           </a:p>
           <a:p>
-            <a:pPr algn="l" indent="0" marL="0">
+            <a:pPr marL="0" indent="0" algn="l">
               <a:buNone/>
             </a:pPr>
             <a:r>
@@ -3738,7 +3745,7 @@
             <a:endParaRPr lang="en-US" sz="1720" dirty="0"/>
           </a:p>
           <a:p>
-            <a:pPr algn="l" indent="0" marL="0">
+            <a:pPr marL="0" indent="0" algn="l">
               <a:buNone/>
             </a:pPr>
             <a:r>
@@ -3755,7 +3762,7 @@
             <a:endParaRPr lang="en-US" sz="1720" dirty="0"/>
           </a:p>
           <a:p>
-            <a:pPr algn="l" indent="0" marL="0">
+            <a:pPr marL="0" indent="0" algn="l">
               <a:buNone/>
             </a:pPr>
             <a:r>
@@ -3772,13 +3779,13 @@
             <a:endParaRPr lang="en-US" sz="1720" dirty="0"/>
           </a:p>
           <a:p>
-            <a:pPr algn="l" indent="0" marL="0">
+            <a:pPr marL="0" indent="0" algn="l">
               <a:buNone/>
             </a:pPr>
             <a:endParaRPr lang="en-US" sz="1720" dirty="0"/>
           </a:p>
           <a:p>
-            <a:pPr algn="l" indent="0" marL="0">
+            <a:pPr marL="0" indent="0" algn="l">
               <a:buNone/>
             </a:pPr>
             <a:r>
@@ -3822,13 +3829,20 @@
             <a:prstDash val="solid"/>
           </a:ln>
           <a:effectLst>
-            <a:outerShdw sx="100000" sy="100000" kx="0" ky="0" algn="bl" rotWithShape="0" blurRad="19050" dist="50800" dir="2700000">
+            <a:outerShdw blurRad="19050" dist="50800" dir="2700000" algn="bl" rotWithShape="0">
               <a:srgbClr val="888888">
                 <a:alpha val="12000"/>
               </a:srgbClr>
             </a:outerShdw>
           </a:effectLst>
         </p:spPr>
+        <p:txBody>
+          <a:bodyPr/>
+          <a:lstStyle/>
+          <a:p>
+            <a:endParaRPr lang="en-CA"/>
+          </a:p>
+        </p:txBody>
       </p:sp>
       <p:sp>
         <p:nvSpPr>
@@ -3856,6 +3870,13 @@
             <a:prstDash val="solid"/>
           </a:ln>
         </p:spPr>
+        <p:txBody>
+          <a:bodyPr/>
+          <a:lstStyle/>
+          <a:p>
+            <a:endParaRPr lang="en-CA"/>
+          </a:p>
+        </p:txBody>
       </p:sp>
       <p:sp>
         <p:nvSpPr>
@@ -3880,7 +3901,7 @@
           </a:bodyPr>
           <a:lstStyle/>
           <a:p>
-            <a:pPr algn="l" indent="0" marL="0">
+            <a:pPr marL="0" indent="0" algn="l">
               <a:buNone/>
             </a:pPr>
             <a:r>
@@ -3924,6 +3945,13 @@
             <a:prstDash val="solid"/>
           </a:ln>
         </p:spPr>
+        <p:txBody>
+          <a:bodyPr/>
+          <a:lstStyle/>
+          <a:p>
+            <a:endParaRPr lang="en-CA"/>
+          </a:p>
+        </p:txBody>
       </p:sp>
       <p:sp>
         <p:nvSpPr>
@@ -3948,7 +3976,7 @@
           </a:bodyPr>
           <a:lstStyle/>
           <a:p>
-            <a:pPr algn="ctr" indent="0" marL="0">
+            <a:pPr marL="0" indent="0" algn="ctr">
               <a:buNone/>
             </a:pPr>
             <a:r>
@@ -3989,7 +4017,7 @@
           </a:bodyPr>
           <a:lstStyle/>
           <a:p>
-            <a:pPr algn="ctr" indent="0" marL="0">
+            <a:pPr marL="0" indent="0" algn="ctr">
               <a:buNone/>
             </a:pPr>
             <a:r>
@@ -4033,6 +4061,13 @@
             <a:prstDash val="solid"/>
           </a:ln>
         </p:spPr>
+        <p:txBody>
+          <a:bodyPr/>
+          <a:lstStyle/>
+          <a:p>
+            <a:endParaRPr lang="en-CA"/>
+          </a:p>
+        </p:txBody>
       </p:sp>
       <p:sp>
         <p:nvSpPr>
@@ -4057,7 +4092,7 @@
           </a:bodyPr>
           <a:lstStyle/>
           <a:p>
-            <a:pPr algn="ctr" indent="0" marL="0">
+            <a:pPr marL="0" indent="0" algn="ctr">
               <a:buNone/>
             </a:pPr>
             <a:r>
@@ -4098,7 +4133,7 @@
           </a:bodyPr>
           <a:lstStyle/>
           <a:p>
-            <a:pPr algn="ctr" indent="0" marL="0">
+            <a:pPr marL="0" indent="0" algn="ctr">
               <a:buNone/>
             </a:pPr>
             <a:r>
@@ -4142,6 +4177,13 @@
             <a:prstDash val="solid"/>
           </a:ln>
         </p:spPr>
+        <p:txBody>
+          <a:bodyPr/>
+          <a:lstStyle/>
+          <a:p>
+            <a:endParaRPr lang="en-CA"/>
+          </a:p>
+        </p:txBody>
       </p:sp>
       <p:sp>
         <p:nvSpPr>
@@ -4166,7 +4208,7 @@
           </a:bodyPr>
           <a:lstStyle/>
           <a:p>
-            <a:pPr algn="ctr" indent="0" marL="0">
+            <a:pPr marL="0" indent="0" algn="ctr">
               <a:buNone/>
             </a:pPr>
             <a:r>
@@ -4207,7 +4249,7 @@
           </a:bodyPr>
           <a:lstStyle/>
           <a:p>
-            <a:pPr algn="ctr" indent="0" marL="0">
+            <a:pPr marL="0" indent="0" algn="ctr">
               <a:buNone/>
             </a:pPr>
             <a:r>
@@ -4248,7 +4290,7 @@
           </a:bodyPr>
           <a:lstStyle/>
           <a:p>
-            <a:pPr algn="ctr" indent="0" marL="0">
+            <a:pPr marL="0" indent="0" algn="ctr">
               <a:buNone/>
             </a:pPr>
             <a:r>
@@ -4289,7 +4331,7 @@
           </a:bodyPr>
           <a:lstStyle/>
           <a:p>
-            <a:pPr algn="ctr" indent="0" marL="0">
+            <a:pPr marL="0" indent="0" algn="ctr">
               <a:buNone/>
             </a:pPr>
             <a:r>
@@ -4333,13 +4375,20 @@
             <a:prstDash val="solid"/>
           </a:ln>
           <a:effectLst>
-            <a:outerShdw sx="100000" sy="100000" kx="0" ky="0" algn="bl" rotWithShape="0" blurRad="19050" dist="50800" dir="2700000">
+            <a:outerShdw blurRad="19050" dist="50800" dir="2700000" algn="bl" rotWithShape="0">
               <a:srgbClr val="888888">
                 <a:alpha val="12000"/>
               </a:srgbClr>
             </a:outerShdw>
           </a:effectLst>
         </p:spPr>
+        <p:txBody>
+          <a:bodyPr/>
+          <a:lstStyle/>
+          <a:p>
+            <a:endParaRPr lang="en-CA"/>
+          </a:p>
+        </p:txBody>
       </p:sp>
       <p:sp>
         <p:nvSpPr>
@@ -4367,6 +4416,13 @@
             <a:prstDash val="solid"/>
           </a:ln>
         </p:spPr>
+        <p:txBody>
+          <a:bodyPr/>
+          <a:lstStyle/>
+          <a:p>
+            <a:endParaRPr lang="en-CA"/>
+          </a:p>
+        </p:txBody>
       </p:sp>
       <p:sp>
         <p:nvSpPr>
@@ -4391,7 +4447,7 @@
           </a:bodyPr>
           <a:lstStyle/>
           <a:p>
-            <a:pPr algn="l" indent="0" marL="0">
+            <a:pPr marL="0" indent="0" algn="l">
               <a:buNone/>
             </a:pPr>
             <a:r>
@@ -4411,14 +4467,14 @@
       </p:sp>
       <p:pic>
         <p:nvPicPr>
-          <p:cNvPr id="90" name="Image 2" descr="Row-normalized confusion matrix for the selected real-only scikit-learn random forest">    </p:cNvPr>
+          <p:cNvPr id="90" name="Image 2" descr="Row-normalized confusion matrix for the selected real-only scikit-learn random forest"/>
           <p:cNvPicPr>
             <a:picLocks noChangeAspect="1"/>
           </p:cNvPicPr>
           <p:nvPr/>
         </p:nvPicPr>
         <p:blipFill>
-          <a:blip r:embed="rId3"/>
+          <a:blip r:embed="rId5"/>
           <a:stretch>
             <a:fillRect/>
           </a:stretch>
@@ -4459,13 +4515,20 @@
             <a:prstDash val="solid"/>
           </a:ln>
           <a:effectLst>
-            <a:outerShdw sx="100000" sy="100000" kx="0" ky="0" algn="bl" rotWithShape="0" blurRad="19050" dist="50800" dir="2700000">
+            <a:outerShdw blurRad="19050" dist="50800" dir="2700000" algn="bl" rotWithShape="0">
               <a:srgbClr val="888888">
                 <a:alpha val="12000"/>
               </a:srgbClr>
             </a:outerShdw>
           </a:effectLst>
         </p:spPr>
+        <p:txBody>
+          <a:bodyPr/>
+          <a:lstStyle/>
+          <a:p>
+            <a:endParaRPr lang="en-CA"/>
+          </a:p>
+        </p:txBody>
       </p:sp>
       <p:sp>
         <p:nvSpPr>
@@ -4493,6 +4556,13 @@
             <a:prstDash val="solid"/>
           </a:ln>
         </p:spPr>
+        <p:txBody>
+          <a:bodyPr/>
+          <a:lstStyle/>
+          <a:p>
+            <a:endParaRPr lang="en-CA"/>
+          </a:p>
+        </p:txBody>
       </p:sp>
       <p:sp>
         <p:nvSpPr>
@@ -4517,7 +4587,7 @@
           </a:bodyPr>
           <a:lstStyle/>
           <a:p>
-            <a:pPr algn="l" indent="0" marL="0">
+            <a:pPr marL="0" indent="0" algn="l">
               <a:buNone/>
             </a:pPr>
             <a:r>
@@ -4558,7 +4628,7 @@
           </a:bodyPr>
           <a:lstStyle/>
           <a:p>
-            <a:pPr algn="ctr" indent="0" marL="0">
+            <a:pPr marL="0" indent="0" algn="ctr">
               <a:buNone/>
             </a:pPr>
             <a:r>
@@ -4602,13 +4672,20 @@
             <a:prstDash val="solid"/>
           </a:ln>
           <a:effectLst>
-            <a:outerShdw sx="100000" sy="100000" kx="0" ky="0" algn="bl" rotWithShape="0" blurRad="19050" dist="50800" dir="2700000">
+            <a:outerShdw blurRad="19050" dist="50800" dir="2700000" algn="bl" rotWithShape="0">
               <a:srgbClr val="888888">
                 <a:alpha val="12000"/>
               </a:srgbClr>
             </a:outerShdw>
           </a:effectLst>
         </p:spPr>
+        <p:txBody>
+          <a:bodyPr/>
+          <a:lstStyle/>
+          <a:p>
+            <a:endParaRPr lang="en-CA"/>
+          </a:p>
+        </p:txBody>
       </p:sp>
       <p:sp>
         <p:nvSpPr>
@@ -4636,6 +4713,13 @@
             <a:prstDash val="solid"/>
           </a:ln>
         </p:spPr>
+        <p:txBody>
+          <a:bodyPr/>
+          <a:lstStyle/>
+          <a:p>
+            <a:endParaRPr lang="en-CA"/>
+          </a:p>
+        </p:txBody>
       </p:sp>
       <p:sp>
         <p:nvSpPr>
@@ -4660,7 +4744,7 @@
           </a:bodyPr>
           <a:lstStyle/>
           <a:p>
-            <a:pPr algn="l" indent="0" marL="0">
+            <a:pPr marL="0" indent="0" algn="l">
               <a:buNone/>
             </a:pPr>
             <a:r>
@@ -4701,7 +4785,7 @@
           </a:bodyPr>
           <a:lstStyle/>
           <a:p>
-            <a:pPr algn="l" indent="0" marL="0">
+            <a:pPr marL="0" indent="0" algn="l">
               <a:buNone/>
             </a:pPr>
             <a:r>
@@ -4718,7 +4802,7 @@
             <a:endParaRPr lang="en-US" sz="1150" dirty="0"/>
           </a:p>
           <a:p>
-            <a:pPr algn="l" indent="0" marL="0">
+            <a:pPr marL="0" indent="0" algn="l">
               <a:buNone/>
             </a:pPr>
             <a:r>
@@ -4735,7 +4819,7 @@
             <a:endParaRPr lang="en-US" sz="1150" dirty="0"/>
           </a:p>
           <a:p>
-            <a:pPr algn="l" indent="0" marL="0">
+            <a:pPr marL="0" indent="0" algn="l">
               <a:buNone/>
             </a:pPr>
             <a:r>
@@ -4752,7 +4836,7 @@
             <a:endParaRPr lang="en-US" sz="1150" dirty="0"/>
           </a:p>
           <a:p>
-            <a:pPr algn="l" indent="0" marL="0">
+            <a:pPr marL="0" indent="0" algn="l">
               <a:buNone/>
             </a:pPr>
             <a:r>
@@ -4769,7 +4853,7 @@
             <a:endParaRPr lang="en-US" sz="1150" dirty="0"/>
           </a:p>
           <a:p>
-            <a:pPr algn="l" indent="0" marL="0">
+            <a:pPr marL="0" indent="0" algn="l">
               <a:buNone/>
             </a:pPr>
             <a:r>
@@ -4810,7 +4894,7 @@
           </a:bodyPr>
           <a:lstStyle/>
           <a:p>
-            <a:pPr algn="ctr" indent="0" marL="0">
+            <a:pPr marL="0" indent="0" algn="ctr">
               <a:buNone/>
             </a:pPr>
             <a:r>
@@ -5129,4 +5213,319 @@
     </a:ext>
   </a:extLst>
 </a:theme>
+</file>
+
+<file path=ppt/theme/theme2.xml><?xml version="1.0" encoding="utf-8"?>
+<a:theme xmlns:a="http://schemas.openxmlformats.org/drawingml/2006/main" name="Office Theme">
+  <a:themeElements>
+    <a:clrScheme name="Office">
+      <a:dk1>
+        <a:sysClr val="windowText" lastClr="000000"/>
+      </a:dk1>
+      <a:lt1>
+        <a:sysClr val="window" lastClr="FFFFFF"/>
+      </a:lt1>
+      <a:dk2>
+        <a:srgbClr val="0E2841"/>
+      </a:dk2>
+      <a:lt2>
+        <a:srgbClr val="E8E8E8"/>
+      </a:lt2>
+      <a:accent1>
+        <a:srgbClr val="156082"/>
+      </a:accent1>
+      <a:accent2>
+        <a:srgbClr val="E97132"/>
+      </a:accent2>
+      <a:accent3>
+        <a:srgbClr val="196B24"/>
+      </a:accent3>
+      <a:accent4>
+        <a:srgbClr val="0F9ED5"/>
+      </a:accent4>
+      <a:accent5>
+        <a:srgbClr val="A02B93"/>
+      </a:accent5>
+      <a:accent6>
+        <a:srgbClr val="4EA72E"/>
+      </a:accent6>
+      <a:hlink>
+        <a:srgbClr val="467886"/>
+      </a:hlink>
+      <a:folHlink>
+        <a:srgbClr val="96607D"/>
+      </a:folHlink>
+    </a:clrScheme>
+    <a:fontScheme name="Office">
+      <a:majorFont>
+        <a:latin typeface="Aptos Display" panose="02110004020202020204"/>
+        <a:ea typeface=""/>
+        <a:cs typeface=""/>
+        <a:font script="Jpan" typeface="游ゴシック Light"/>
+        <a:font script="Hang" typeface="맑은 고딕"/>
+        <a:font script="Hans" typeface="等线 Light"/>
+        <a:font script="Hant" typeface="新細明體"/>
+        <a:font script="Arab" typeface="Times New Roman"/>
+        <a:font script="Hebr" typeface="Times New Roman"/>
+        <a:font script="Thai" typeface="Angsana New"/>
+        <a:font script="Ethi" typeface="Nyala"/>
+        <a:font script="Beng" typeface="Vrinda"/>
+        <a:font script="Gujr" typeface="Shruti"/>
+        <a:font script="Khmr" typeface="MoolBoran"/>
+        <a:font script="Knda" typeface="Tunga"/>
+        <a:font script="Guru" typeface="Raavi"/>
+        <a:font script="Cans" typeface="Euphemia"/>
+        <a:font script="Cher" typeface="Plantagenet Cherokee"/>
+        <a:font script="Yiii" typeface="Microsoft Yi Baiti"/>
+        <a:font script="Tibt" typeface="Microsoft Himalaya"/>
+        <a:font script="Thaa" typeface="MV Boli"/>
+        <a:font script="Deva" typeface="Mangal"/>
+        <a:font script="Telu" typeface="Gautami"/>
+        <a:font script="Taml" typeface="Latha"/>
+        <a:font script="Syrc" typeface="Estrangelo Edessa"/>
+        <a:font script="Orya" typeface="Kalinga"/>
+        <a:font script="Mlym" typeface="Kartika"/>
+        <a:font script="Laoo" typeface="DokChampa"/>
+        <a:font script="Sinh" typeface="Iskoola Pota"/>
+        <a:font script="Mong" typeface="Mongolian Baiti"/>
+        <a:font script="Viet" typeface="Times New Roman"/>
+        <a:font script="Uigh" typeface="Microsoft Uighur"/>
+        <a:font script="Geor" typeface="Sylfaen"/>
+        <a:font script="Armn" typeface="Arial"/>
+        <a:font script="Bugi" typeface="Leelawadee UI"/>
+        <a:font script="Bopo" typeface="Microsoft JhengHei"/>
+        <a:font script="Java" typeface="Javanese Text"/>
+        <a:font script="Lisu" typeface="Segoe UI"/>
+        <a:font script="Mymr" typeface="Myanmar Text"/>
+        <a:font script="Nkoo" typeface="Ebrima"/>
+        <a:font script="Olck" typeface="Nirmala UI"/>
+        <a:font script="Osma" typeface="Ebrima"/>
+        <a:font script="Phag" typeface="Phagspa"/>
+        <a:font script="Syrn" typeface="Estrangelo Edessa"/>
+        <a:font script="Syrj" typeface="Estrangelo Edessa"/>
+        <a:font script="Syre" typeface="Estrangelo Edessa"/>
+        <a:font script="Sora" typeface="Nirmala UI"/>
+        <a:font script="Tale" typeface="Microsoft Tai Le"/>
+        <a:font script="Talu" typeface="Microsoft New Tai Lue"/>
+        <a:font script="Tfng" typeface="Ebrima"/>
+      </a:majorFont>
+      <a:minorFont>
+        <a:latin typeface="Aptos" panose="02110004020202020204"/>
+        <a:ea typeface=""/>
+        <a:cs typeface=""/>
+        <a:font script="Jpan" typeface="游ゴシック"/>
+        <a:font script="Hang" typeface="맑은 고딕"/>
+        <a:font script="Hans" typeface="等线"/>
+        <a:font script="Hant" typeface="新細明體"/>
+        <a:font script="Arab" typeface="Arial"/>
+        <a:font script="Hebr" typeface="Arial"/>
+        <a:font script="Thai" typeface="Cordia New"/>
+        <a:font script="Ethi" typeface="Nyala"/>
+        <a:font script="Beng" typeface="Vrinda"/>
+        <a:font script="Gujr" typeface="Shruti"/>
+        <a:font script="Khmr" typeface="DaunPenh"/>
+        <a:font script="Knda" typeface="Tunga"/>
+        <a:font script="Guru" typeface="Raavi"/>
+        <a:font script="Cans" typeface="Euphemia"/>
+        <a:font script="Cher" typeface="Plantagenet Cherokee"/>
+        <a:font script="Yiii" typeface="Microsoft Yi Baiti"/>
+        <a:font script="Tibt" typeface="Microsoft Himalaya"/>
+        <a:font script="Thaa" typeface="MV Boli"/>
+        <a:font script="Deva" typeface="Mangal"/>
+        <a:font script="Telu" typeface="Gautami"/>
+        <a:font script="Taml" typeface="Latha"/>
+        <a:font script="Syrc" typeface="Estrangelo Edessa"/>
+        <a:font script="Orya" typeface="Kalinga"/>
+        <a:font script="Mlym" typeface="Kartika"/>
+        <a:font script="Laoo" typeface="DokChampa"/>
+        <a:font script="Sinh" typeface="Iskoola Pota"/>
+        <a:font script="Mong" typeface="Mongolian Baiti"/>
+        <a:font script="Viet" typeface="Arial"/>
+        <a:font script="Uigh" typeface="Microsoft Uighur"/>
+        <a:font script="Geor" typeface="Sylfaen"/>
+        <a:font script="Armn" typeface="Arial"/>
+        <a:font script="Bugi" typeface="Leelawadee UI"/>
+        <a:font script="Bopo" typeface="Microsoft JhengHei"/>
+        <a:font script="Java" typeface="Javanese Text"/>
+        <a:font script="Lisu" typeface="Segoe UI"/>
+        <a:font script="Mymr" typeface="Myanmar Text"/>
+        <a:font script="Nkoo" typeface="Ebrima"/>
+        <a:font script="Olck" typeface="Nirmala UI"/>
+        <a:font script="Osma" typeface="Ebrima"/>
+        <a:font script="Phag" typeface="Phagspa"/>
+        <a:font script="Syrn" typeface="Estrangelo Edessa"/>
+        <a:font script="Syrj" typeface="Estrangelo Edessa"/>
+        <a:font script="Syre" typeface="Estrangelo Edessa"/>
+        <a:font script="Sora" typeface="Nirmala UI"/>
+        <a:font script="Tale" typeface="Microsoft Tai Le"/>
+        <a:font script="Talu" typeface="Microsoft New Tai Lue"/>
+        <a:font script="Tfng" typeface="Ebrima"/>
+      </a:minorFont>
+    </a:fontScheme>
+    <a:fmtScheme name="Office">
+      <a:fillStyleLst>
+        <a:solidFill>
+          <a:schemeClr val="phClr"/>
+        </a:solidFill>
+        <a:gradFill rotWithShape="1">
+          <a:gsLst>
+            <a:gs pos="0">
+              <a:schemeClr val="phClr">
+                <a:lumMod val="110000"/>
+                <a:satMod val="105000"/>
+                <a:tint val="67000"/>
+              </a:schemeClr>
+            </a:gs>
+            <a:gs pos="50000">
+              <a:schemeClr val="phClr">
+                <a:lumMod val="105000"/>
+                <a:satMod val="103000"/>
+                <a:tint val="73000"/>
+              </a:schemeClr>
+            </a:gs>
+            <a:gs pos="100000">
+              <a:schemeClr val="phClr">
+                <a:lumMod val="105000"/>
+                <a:satMod val="109000"/>
+                <a:tint val="81000"/>
+              </a:schemeClr>
+            </a:gs>
+          </a:gsLst>
+          <a:lin ang="5400000" scaled="0"/>
+        </a:gradFill>
+        <a:gradFill rotWithShape="1">
+          <a:gsLst>
+            <a:gs pos="0">
+              <a:schemeClr val="phClr">
+                <a:satMod val="103000"/>
+                <a:lumMod val="102000"/>
+                <a:tint val="94000"/>
+              </a:schemeClr>
+            </a:gs>
+            <a:gs pos="50000">
+              <a:schemeClr val="phClr">
+                <a:satMod val="110000"/>
+                <a:lumMod val="100000"/>
+                <a:shade val="100000"/>
+              </a:schemeClr>
+            </a:gs>
+            <a:gs pos="100000">
+              <a:schemeClr val="phClr">
+                <a:lumMod val="99000"/>
+                <a:satMod val="120000"/>
+                <a:shade val="78000"/>
+              </a:schemeClr>
+            </a:gs>
+          </a:gsLst>
+          <a:lin ang="5400000" scaled="0"/>
+        </a:gradFill>
+      </a:fillStyleLst>
+      <a:lnStyleLst>
+        <a:ln w="12700" cap="flat" cmpd="sng" algn="ctr">
+          <a:solidFill>
+            <a:schemeClr val="phClr"/>
+          </a:solidFill>
+          <a:prstDash val="solid"/>
+          <a:miter lim="800000"/>
+        </a:ln>
+        <a:ln w="19050" cap="flat" cmpd="sng" algn="ctr">
+          <a:solidFill>
+            <a:schemeClr val="phClr"/>
+          </a:solidFill>
+          <a:prstDash val="solid"/>
+          <a:miter lim="800000"/>
+        </a:ln>
+        <a:ln w="25400" cap="flat" cmpd="sng" algn="ctr">
+          <a:solidFill>
+            <a:schemeClr val="phClr"/>
+          </a:solidFill>
+          <a:prstDash val="solid"/>
+          <a:miter lim="800000"/>
+        </a:ln>
+      </a:lnStyleLst>
+      <a:effectStyleLst>
+        <a:effectStyle>
+          <a:effectLst/>
+        </a:effectStyle>
+        <a:effectStyle>
+          <a:effectLst/>
+        </a:effectStyle>
+        <a:effectStyle>
+          <a:effectLst>
+            <a:outerShdw blurRad="57150" dist="19050" dir="5400000" algn="ctr" rotWithShape="0">
+              <a:srgbClr val="000000">
+                <a:alpha val="63000"/>
+              </a:srgbClr>
+            </a:outerShdw>
+          </a:effectLst>
+        </a:effectStyle>
+      </a:effectStyleLst>
+      <a:bgFillStyleLst>
+        <a:solidFill>
+          <a:schemeClr val="phClr"/>
+        </a:solidFill>
+        <a:solidFill>
+          <a:schemeClr val="phClr">
+            <a:tint val="95000"/>
+            <a:satMod val="170000"/>
+          </a:schemeClr>
+        </a:solidFill>
+        <a:gradFill rotWithShape="1">
+          <a:gsLst>
+            <a:gs pos="0">
+              <a:schemeClr val="phClr">
+                <a:tint val="93000"/>
+                <a:satMod val="150000"/>
+                <a:shade val="98000"/>
+                <a:lumMod val="102000"/>
+              </a:schemeClr>
+            </a:gs>
+            <a:gs pos="50000">
+              <a:schemeClr val="phClr">
+                <a:tint val="98000"/>
+                <a:satMod val="130000"/>
+                <a:shade val="90000"/>
+                <a:lumMod val="103000"/>
+              </a:schemeClr>
+            </a:gs>
+            <a:gs pos="100000">
+              <a:schemeClr val="phClr">
+                <a:shade val="63000"/>
+                <a:satMod val="120000"/>
+              </a:schemeClr>
+            </a:gs>
+          </a:gsLst>
+          <a:lin ang="5400000" scaled="0"/>
+        </a:gradFill>
+      </a:bgFillStyleLst>
+    </a:fmtScheme>
+  </a:themeElements>
+  <a:objectDefaults>
+    <a:lnDef>
+      <a:spPr/>
+      <a:bodyPr/>
+      <a:lstStyle/>
+      <a:style>
+        <a:lnRef idx="2">
+          <a:schemeClr val="accent1"/>
+        </a:lnRef>
+        <a:fillRef idx="0">
+          <a:schemeClr val="accent1"/>
+        </a:fillRef>
+        <a:effectRef idx="1">
+          <a:schemeClr val="accent1"/>
+        </a:effectRef>
+        <a:fontRef idx="minor">
+          <a:schemeClr val="tx1"/>
+        </a:fontRef>
+      </a:style>
+    </a:lnDef>
+  </a:objectDefaults>
+  <a:extraClrSchemeLst/>
+  <a:extLst>
+    <a:ext uri="{05A4C25C-085E-4340-85A3-A5531E510DB2}">
+      <thm15:themeFamily xmlns:thm15="http://schemas.microsoft.com/office/thememl/2012/main" name="Office Theme" id="{2E142A2C-CD16-42D6-873A-C26D2A0506FA}" vid="{1BDDFF52-6CD6-40A5-AB3C-68EB2F1E4D0A}"/>
+    </a:ext>
+  </a:extLst>
+</a:theme>
 </file>
</xml_diff>